<commit_message>
Dekkets skjermbilder viste feil selskapsnavn
Bildene ble tatt mens en etterlatt test-tenant hadde kapret vertsnavnet
127.0.0.1, så toppfeltet sto med «Alfa» i stedet for Livsarkivet — også på
lysbilde 7, karenstiden, som er dekkets viktigste bilde. Agenten var ærlig og
satte «demo-tenant Alfa» som bildetekst, men et investordekk der
flaggskipbildet bærer et fremmed selskapsnavn er ikke noe man forklarer seg
ut av i rommet.

Nye bilder tatt etter at kapringen ble ryddet, fra samme rigg. De viser
dessuten de fire nye funksjonene: beredskapsscoren og «kjente spørsmål» i
hvelvet, og «én ting om gangen» i etterlattevisningen. Bildeteksten er nå
«skjermbilde fra appen · demodata · 390×844».

Co-Authored-By: Claude Opus 5 <noreply@anthropic.com>
Claude-Session: https://claude.ai/code/session_01C3DfPiduFdmuK7cNta481y
</commit_message>
<xml_diff>
--- a/livsarkivet/docs/investordekk.pptx
+++ b/livsarkivet/docs/investordekk.pptx
@@ -2514,11 +2514,11 @@
         <p:spPr>
           <a:xfrm>
             <a:off x="685800" y="2606040"/>
-            <a:ext cx="5669280" cy="3429000"/>
+            <a:ext cx="5669280" cy="3200400"/>
           </a:xfrm>
           <a:prstGeom prst="roundRect">
             <a:avLst>
-              <a:gd name="adj" fmla="val 2400"/>
+              <a:gd name="adj" fmla="val 2571"/>
             </a:avLst>
           </a:prstGeom>
           <a:solidFill>
@@ -2541,11 +2541,11 @@
         <p:spPr>
           <a:xfrm>
             <a:off x="6492240" y="2606040"/>
-            <a:ext cx="5010912" cy="3429000"/>
+            <a:ext cx="5010912" cy="3200400"/>
           </a:xfrm>
           <a:prstGeom prst="roundRect">
             <a:avLst>
-              <a:gd name="adj" fmla="val 2400"/>
+              <a:gd name="adj" fmla="val 2571"/>
             </a:avLst>
           </a:prstGeom>
           <a:solidFill>
@@ -2645,7 +2645,7 @@
         </p:nvSpPr>
         <p:spPr>
           <a:xfrm>
-            <a:off x="1005840" y="3246120"/>
+            <a:off x="1005840" y="3200400"/>
             <a:ext cx="5029200" cy="502920"/>
           </a:xfrm>
           <a:prstGeom prst="rect">
@@ -2687,7 +2687,7 @@
         </p:nvSpPr>
         <p:spPr>
           <a:xfrm>
-            <a:off x="6812280" y="3246120"/>
+            <a:off x="6812280" y="3200400"/>
             <a:ext cx="4389120" cy="502920"/>
           </a:xfrm>
           <a:prstGeom prst="rect">
@@ -2729,7 +2729,7 @@
         </p:nvSpPr>
         <p:spPr>
           <a:xfrm>
-            <a:off x="1005840" y="3794760"/>
+            <a:off x="1005840" y="3712464"/>
             <a:ext cx="5029200" cy="502920"/>
           </a:xfrm>
           <a:prstGeom prst="rect">
@@ -2771,7 +2771,7 @@
         </p:nvSpPr>
         <p:spPr>
           <a:xfrm>
-            <a:off x="6812280" y="3794760"/>
+            <a:off x="6812280" y="3712464"/>
             <a:ext cx="4389120" cy="502920"/>
           </a:xfrm>
           <a:prstGeom prst="rect">
@@ -2813,7 +2813,7 @@
         </p:nvSpPr>
         <p:spPr>
           <a:xfrm>
-            <a:off x="1005840" y="4343400"/>
+            <a:off x="1005840" y="4224528"/>
             <a:ext cx="5029200" cy="502920"/>
           </a:xfrm>
           <a:prstGeom prst="rect">
@@ -2855,7 +2855,7 @@
         </p:nvSpPr>
         <p:spPr>
           <a:xfrm>
-            <a:off x="6812280" y="4343400"/>
+            <a:off x="6812280" y="4224528"/>
             <a:ext cx="4389120" cy="502920"/>
           </a:xfrm>
           <a:prstGeom prst="rect">
@@ -2897,7 +2897,7 @@
         </p:nvSpPr>
         <p:spPr>
           <a:xfrm>
-            <a:off x="1005840" y="4892040"/>
+            <a:off x="1005840" y="4736592"/>
             <a:ext cx="5029200" cy="502920"/>
           </a:xfrm>
           <a:prstGeom prst="rect">
@@ -2939,7 +2939,7 @@
         </p:nvSpPr>
         <p:spPr>
           <a:xfrm>
-            <a:off x="6812280" y="4892040"/>
+            <a:off x="6812280" y="4736592"/>
             <a:ext cx="4389120" cy="502920"/>
           </a:xfrm>
           <a:prstGeom prst="rect">
@@ -2981,7 +2981,7 @@
         </p:nvSpPr>
         <p:spPr>
           <a:xfrm>
-            <a:off x="1005840" y="5440680"/>
+            <a:off x="1005840" y="5248656"/>
             <a:ext cx="5029200" cy="502920"/>
           </a:xfrm>
           <a:prstGeom prst="rect">
@@ -3023,7 +3023,7 @@
         </p:nvSpPr>
         <p:spPr>
           <a:xfrm>
-            <a:off x="6812280" y="5440680"/>
+            <a:off x="6812280" y="5248656"/>
             <a:ext cx="4389120" cy="502920"/>
           </a:xfrm>
           <a:prstGeom prst="rect">
@@ -3065,8 +3065,8 @@
         </p:nvSpPr>
         <p:spPr>
           <a:xfrm>
-            <a:off x="685800" y="6172200"/>
-            <a:ext cx="10424160" cy="411480"/>
+            <a:off x="685800" y="5989320"/>
+            <a:ext cx="10149840" cy="292608"/>
           </a:xfrm>
           <a:prstGeom prst="rect">
             <a:avLst/>
@@ -3080,12 +3080,12 @@
           <a:p>
             <a:pPr algn="l" indent="0" marL="0">
               <a:lnSpc>
-                <a:spcPts val="1633"/>
-              </a:lnSpc>
-              <a:buNone/>
-            </a:pPr>
-            <a:r>
-              <a:rPr lang="en-US" sz="1150" dirty="0">
+                <a:spcPts val="1562"/>
+              </a:lnSpc>
+              <a:buNone/>
+            </a:pPr>
+            <a:r>
+              <a:rPr lang="en-US" sz="1100" dirty="0">
                 <a:solidFill>
                   <a:srgbClr val="EDF2F0"/>
                 </a:solidFill>
@@ -3093,9 +3093,9 @@
                 <a:ea typeface="Calibri" pitchFamily="34" charset="-122"/>
                 <a:cs typeface="Calibri" pitchFamily="34" charset="-120"/>
               </a:rPr>
-              <a:t>At staten har bygget den registerbaserte delen er bra for oss: den tar bort den delen vi ville tapt på. Vi har strøket «egen økonomisk oversikt for etterlatte» fra roadmapen med den begrunnelsen.</a:t>
-            </a:r>
-            <a:endParaRPr lang="en-US" sz="1150" dirty="0"/>
+              <a:t>At staten tok den registerbaserte delen er bra for oss. «Egen økonomisk oversikt» er strøket fra roadmapen med den begrunnelsen.</a:t>
+            </a:r>
+            <a:endParaRPr lang="en-US" sz="1100" dirty="0"/>
           </a:p>
         </p:txBody>
       </p:sp>
@@ -3107,7 +3107,7 @@
         </p:nvSpPr>
         <p:spPr>
           <a:xfrm>
-            <a:off x="685800" y="6583680"/>
+            <a:off x="685800" y="6400800"/>
             <a:ext cx="10180015" cy="411480"/>
           </a:xfrm>
           <a:prstGeom prst="rect">
@@ -3452,11 +3452,11 @@
         <p:spPr>
           <a:xfrm>
             <a:off x="685800" y="4572000"/>
-            <a:ext cx="6309360" cy="1463040"/>
+            <a:ext cx="6309360" cy="1371600"/>
           </a:xfrm>
           <a:prstGeom prst="roundRect">
             <a:avLst>
-              <a:gd name="adj" fmla="val 5625"/>
+              <a:gd name="adj" fmla="val 6000"/>
             </a:avLst>
           </a:prstGeom>
           <a:solidFill>
@@ -3610,7 +3610,7 @@
         </p:nvSpPr>
         <p:spPr>
           <a:xfrm>
-            <a:off x="685800" y="6035040"/>
+            <a:off x="685800" y="6172200"/>
             <a:ext cx="10180015" cy="411480"/>
           </a:xfrm>
           <a:prstGeom prst="rect">
@@ -4726,7 +4726,7 @@
         </p:nvSpPr>
         <p:spPr>
           <a:xfrm>
-            <a:off x="685800" y="2286000"/>
+            <a:off x="685800" y="2240280"/>
             <a:ext cx="365760" cy="365760"/>
           </a:xfrm>
           <a:prstGeom prst="rect">
@@ -4765,7 +4765,7 @@
         </p:nvSpPr>
         <p:spPr>
           <a:xfrm>
-            <a:off x="1097280" y="2304288"/>
+            <a:off x="1097280" y="2258568"/>
             <a:ext cx="4480560" cy="658368"/>
           </a:xfrm>
           <a:prstGeom prst="rect">
@@ -4807,7 +4807,7 @@
         </p:nvSpPr>
         <p:spPr>
           <a:xfrm>
-            <a:off x="5806440" y="2304288"/>
+            <a:off x="5806440" y="2258568"/>
             <a:ext cx="5669280" cy="685800"/>
           </a:xfrm>
           <a:prstGeom prst="rect">
@@ -4849,7 +4849,7 @@
         </p:nvSpPr>
         <p:spPr>
           <a:xfrm>
-            <a:off x="685800" y="3072384"/>
+            <a:off x="685800" y="2990088"/>
             <a:ext cx="365760" cy="365760"/>
           </a:xfrm>
           <a:prstGeom prst="rect">
@@ -4888,7 +4888,7 @@
         </p:nvSpPr>
         <p:spPr>
           <a:xfrm>
-            <a:off x="1097280" y="3090672"/>
+            <a:off x="1097280" y="3008376"/>
             <a:ext cx="4480560" cy="658368"/>
           </a:xfrm>
           <a:prstGeom prst="rect">
@@ -4930,7 +4930,7 @@
         </p:nvSpPr>
         <p:spPr>
           <a:xfrm>
-            <a:off x="5806440" y="3090672"/>
+            <a:off x="5806440" y="3008376"/>
             <a:ext cx="5669280" cy="685800"/>
           </a:xfrm>
           <a:prstGeom prst="rect">
@@ -4972,7 +4972,7 @@
         </p:nvSpPr>
         <p:spPr>
           <a:xfrm>
-            <a:off x="685800" y="3858768"/>
+            <a:off x="685800" y="3739896"/>
             <a:ext cx="365760" cy="365760"/>
           </a:xfrm>
           <a:prstGeom prst="rect">
@@ -5011,7 +5011,7 @@
         </p:nvSpPr>
         <p:spPr>
           <a:xfrm>
-            <a:off x="1097280" y="3877056"/>
+            <a:off x="1097280" y="3758184"/>
             <a:ext cx="4480560" cy="658368"/>
           </a:xfrm>
           <a:prstGeom prst="rect">
@@ -5053,7 +5053,7 @@
         </p:nvSpPr>
         <p:spPr>
           <a:xfrm>
-            <a:off x="5806440" y="3877056"/>
+            <a:off x="5806440" y="3758184"/>
             <a:ext cx="5669280" cy="685800"/>
           </a:xfrm>
           <a:prstGeom prst="rect">
@@ -5095,7 +5095,7 @@
         </p:nvSpPr>
         <p:spPr>
           <a:xfrm>
-            <a:off x="685800" y="4645152"/>
+            <a:off x="685800" y="4489704"/>
             <a:ext cx="365760" cy="365760"/>
           </a:xfrm>
           <a:prstGeom prst="rect">
@@ -5134,7 +5134,7 @@
         </p:nvSpPr>
         <p:spPr>
           <a:xfrm>
-            <a:off x="1097280" y="4663440"/>
+            <a:off x="1097280" y="4507992"/>
             <a:ext cx="4480560" cy="658368"/>
           </a:xfrm>
           <a:prstGeom prst="rect">
@@ -5176,7 +5176,7 @@
         </p:nvSpPr>
         <p:spPr>
           <a:xfrm>
-            <a:off x="5806440" y="4663440"/>
+            <a:off x="5806440" y="4507992"/>
             <a:ext cx="5669280" cy="685800"/>
           </a:xfrm>
           <a:prstGeom prst="rect">
@@ -5218,7 +5218,7 @@
         </p:nvSpPr>
         <p:spPr>
           <a:xfrm>
-            <a:off x="685800" y="5431536"/>
+            <a:off x="685800" y="5239512"/>
             <a:ext cx="365760" cy="365760"/>
           </a:xfrm>
           <a:prstGeom prst="rect">
@@ -5257,7 +5257,7 @@
         </p:nvSpPr>
         <p:spPr>
           <a:xfrm>
-            <a:off x="1097280" y="5449824"/>
+            <a:off x="1097280" y="5257800"/>
             <a:ext cx="4480560" cy="658368"/>
           </a:xfrm>
           <a:prstGeom prst="rect">
@@ -5299,7 +5299,7 @@
         </p:nvSpPr>
         <p:spPr>
           <a:xfrm>
-            <a:off x="5806440" y="5449824"/>
+            <a:off x="5806440" y="5257800"/>
             <a:ext cx="5669280" cy="685800"/>
           </a:xfrm>
           <a:prstGeom prst="rect">
@@ -5335,41 +5335,14 @@
       </p:sp>
       <p:sp>
         <p:nvSpPr>
-          <p:cNvPr id="20" name="Shape 18"/>
-          <p:cNvSpPr/>
-          <p:nvPr/>
-        </p:nvSpPr>
-        <p:spPr>
-          <a:xfrm>
-            <a:off x="685800" y="6263640"/>
-            <a:ext cx="10820095" cy="457200"/>
-          </a:xfrm>
-          <a:prstGeom prst="roundRect">
-            <a:avLst>
-              <a:gd name="adj" fmla="val 18000"/>
-            </a:avLst>
-          </a:prstGeom>
-          <a:solidFill>
-            <a:srgbClr val="0E1B25"/>
-          </a:solidFill>
-          <a:ln w="12700">
-            <a:solidFill>
-              <a:srgbClr val="27405A"/>
-            </a:solidFill>
-            <a:prstDash val="solid"/>
-          </a:ln>
-        </p:spPr>
-      </p:sp>
-      <p:sp>
-        <p:nvSpPr>
-          <p:cNvPr id="21" name="Text 19"/>
-          <p:cNvSpPr/>
-          <p:nvPr/>
-        </p:nvSpPr>
-        <p:spPr>
-          <a:xfrm>
-            <a:off x="960120" y="6382512"/>
-            <a:ext cx="10271455" cy="274320"/>
+          <p:cNvPr id="20" name="Text 18"/>
+          <p:cNvSpPr/>
+          <p:nvPr/>
+        </p:nvSpPr>
+        <p:spPr>
+          <a:xfrm>
+            <a:off x="685800" y="5989320"/>
+            <a:ext cx="9966960" cy="548640"/>
           </a:xfrm>
           <a:prstGeom prst="rect">
             <a:avLst/>
@@ -5582,12 +5555,12 @@
         </p:nvSpPr>
         <p:spPr>
           <a:xfrm>
-            <a:off x="685800" y="2514600"/>
-            <a:ext cx="3419856" cy="1828800"/>
+            <a:off x="685800" y="2468880"/>
+            <a:ext cx="3419856" cy="2011680"/>
           </a:xfrm>
           <a:prstGeom prst="roundRect">
             <a:avLst>
-              <a:gd name="adj" fmla="val 4500"/>
+              <a:gd name="adj" fmla="val 4091"/>
             </a:avLst>
           </a:prstGeom>
           <a:solidFill>
@@ -5609,7 +5582,7 @@
         </p:nvSpPr>
         <p:spPr>
           <a:xfrm>
-            <a:off x="960120" y="2743200"/>
+            <a:off x="960120" y="2697480"/>
             <a:ext cx="457200" cy="274320"/>
           </a:xfrm>
           <a:prstGeom prst="rect">
@@ -5648,7 +5621,7 @@
         </p:nvSpPr>
         <p:spPr>
           <a:xfrm>
-            <a:off x="960120" y="3108960"/>
+            <a:off x="960120" y="3063240"/>
             <a:ext cx="2871216" cy="320040"/>
           </a:xfrm>
           <a:prstGeom prst="rect">
@@ -5690,8 +5663,8 @@
         </p:nvSpPr>
         <p:spPr>
           <a:xfrm>
-            <a:off x="960120" y="3520440"/>
-            <a:ext cx="2871216" cy="777240"/>
+            <a:off x="960120" y="3474720"/>
+            <a:ext cx="2871216" cy="868680"/>
           </a:xfrm>
           <a:prstGeom prst="rect">
             <a:avLst/>
@@ -5705,12 +5678,12 @@
           <a:p>
             <a:pPr algn="l" indent="0" marL="0">
               <a:lnSpc>
-                <a:spcPts val="1562"/>
-              </a:lnSpc>
-              <a:buNone/>
-            </a:pPr>
-            <a:r>
-              <a:rPr lang="en-US" sz="1100" dirty="0">
+                <a:spcPts val="1491"/>
+              </a:lnSpc>
+              <a:buNone/>
+            </a:pPr>
+            <a:r>
+              <a:rPr lang="en-US" sz="1050" dirty="0">
                 <a:solidFill>
                   <a:srgbClr val="9FB3AD"/>
                 </a:solidFill>
@@ -5720,7 +5693,7 @@
               </a:rPr>
               <a:t>Behandlingsansvarlig enhet, jurist på de tolv spørsmålene i jurist-briefen, databehandleravtaler. Dette blokkerer alt annet.</a:t>
             </a:r>
-            <a:endParaRPr lang="en-US" sz="1100" dirty="0"/>
+            <a:endParaRPr lang="en-US" sz="1050" dirty="0"/>
           </a:p>
         </p:txBody>
       </p:sp>
@@ -5732,12 +5705,12 @@
         </p:nvSpPr>
         <p:spPr>
           <a:xfrm>
-            <a:off x="4379976" y="2514600"/>
-            <a:ext cx="3419856" cy="1828800"/>
+            <a:off x="4379976" y="2468880"/>
+            <a:ext cx="3419856" cy="2011680"/>
           </a:xfrm>
           <a:prstGeom prst="roundRect">
             <a:avLst>
-              <a:gd name="adj" fmla="val 4500"/>
+              <a:gd name="adj" fmla="val 4091"/>
             </a:avLst>
           </a:prstGeom>
           <a:solidFill>
@@ -5759,7 +5732,7 @@
         </p:nvSpPr>
         <p:spPr>
           <a:xfrm>
-            <a:off x="4654296" y="2743200"/>
+            <a:off x="4654296" y="2697480"/>
             <a:ext cx="457200" cy="274320"/>
           </a:xfrm>
           <a:prstGeom prst="rect">
@@ -5798,7 +5771,7 @@
         </p:nvSpPr>
         <p:spPr>
           <a:xfrm>
-            <a:off x="4654296" y="3108960"/>
+            <a:off x="4654296" y="3063240"/>
             <a:ext cx="2871216" cy="320040"/>
           </a:xfrm>
           <a:prstGeom prst="rect">
@@ -5840,8 +5813,8 @@
         </p:nvSpPr>
         <p:spPr>
           <a:xfrm>
-            <a:off x="4654296" y="3520440"/>
-            <a:ext cx="2871216" cy="777240"/>
+            <a:off x="4654296" y="3474720"/>
+            <a:ext cx="2871216" cy="868680"/>
           </a:xfrm>
           <a:prstGeom prst="rect">
             <a:avLst/>
@@ -5855,12 +5828,12 @@
           <a:p>
             <a:pPr algn="l" indent="0" marL="0">
               <a:lnSpc>
-                <a:spcPts val="1562"/>
-              </a:lnSpc>
-              <a:buNone/>
-            </a:pPr>
-            <a:r>
-              <a:rPr lang="en-US" sz="1100" dirty="0">
+                <a:spcPts val="1491"/>
+              </a:lnSpc>
+              <a:buNone/>
+            </a:pPr>
+            <a:r>
+              <a:rPr lang="en-US" sz="1050" dirty="0">
                 <a:solidFill>
                   <a:srgbClr val="9FB3AD"/>
                 </a:solidFill>
@@ -5870,7 +5843,7 @@
               </a:rPr>
               <a:t>Ingen compliance-funksjon i et forsikringsselskap slipper oss gjennom uten. Rapporten legges frem uredigert.</a:t>
             </a:r>
-            <a:endParaRPr lang="en-US" sz="1100" dirty="0"/>
+            <a:endParaRPr lang="en-US" sz="1050" dirty="0"/>
           </a:p>
         </p:txBody>
       </p:sp>
@@ -5882,12 +5855,12 @@
         </p:nvSpPr>
         <p:spPr>
           <a:xfrm>
-            <a:off x="8074152" y="2514600"/>
-            <a:ext cx="3419856" cy="1828800"/>
+            <a:off x="8074152" y="2468880"/>
+            <a:ext cx="3419856" cy="2011680"/>
           </a:xfrm>
           <a:prstGeom prst="roundRect">
             <a:avLst>
-              <a:gd name="adj" fmla="val 4500"/>
+              <a:gd name="adj" fmla="val 4091"/>
             </a:avLst>
           </a:prstGeom>
           <a:solidFill>
@@ -5909,7 +5882,7 @@
         </p:nvSpPr>
         <p:spPr>
           <a:xfrm>
-            <a:off x="8348472" y="2743200"/>
+            <a:off x="8348472" y="2697480"/>
             <a:ext cx="457200" cy="274320"/>
           </a:xfrm>
           <a:prstGeom prst="rect">
@@ -5948,7 +5921,7 @@
         </p:nvSpPr>
         <p:spPr>
           <a:xfrm>
-            <a:off x="8348472" y="3108960"/>
+            <a:off x="8348472" y="3063240"/>
             <a:ext cx="2871216" cy="320040"/>
           </a:xfrm>
           <a:prstGeom prst="rect">
@@ -5990,8 +5963,8 @@
         </p:nvSpPr>
         <p:spPr>
           <a:xfrm>
-            <a:off x="8348472" y="3520440"/>
-            <a:ext cx="2871216" cy="777240"/>
+            <a:off x="8348472" y="3474720"/>
+            <a:ext cx="2871216" cy="868680"/>
           </a:xfrm>
           <a:prstGeom prst="rect">
             <a:avLst/>
@@ -6005,12 +5978,12 @@
           <a:p>
             <a:pPr algn="l" indent="0" marL="0">
               <a:lnSpc>
-                <a:spcPts val="1562"/>
-              </a:lnSpc>
-              <a:buNone/>
-            </a:pPr>
-            <a:r>
-              <a:rPr lang="en-US" sz="1100" dirty="0">
+                <a:spcPts val="1491"/>
+              </a:lnSpc>
+              <a:buNone/>
+            </a:pPr>
+            <a:r>
+              <a:rPr lang="en-US" sz="1050" dirty="0">
                 <a:solidFill>
                   <a:srgbClr val="9FB3AD"/>
                 </a:solidFill>
@@ -6020,7 +5993,7 @@
               </a:rPr>
               <a:t>Én kanalavtale som gir de første tusen brukerne. Er det ett sted en investor med nettverk er verdt mer enn kapitalen, er det her.</a:t>
             </a:r>
-            <a:endParaRPr lang="en-US" sz="1100" dirty="0"/>
+            <a:endParaRPr lang="en-US" sz="1050" dirty="0"/>
           </a:p>
         </p:txBody>
       </p:sp>
@@ -6399,8 +6372,8 @@
         </p:nvSpPr>
         <p:spPr>
           <a:xfrm>
-            <a:off x="1005840" y="4892040"/>
-            <a:ext cx="914400" cy="777240"/>
+            <a:off x="1005840" y="4937760"/>
+            <a:ext cx="914400" cy="914400"/>
           </a:xfrm>
           <a:prstGeom prst="rect">
             <a:avLst/>
@@ -6438,8 +6411,8 @@
         </p:nvSpPr>
         <p:spPr>
           <a:xfrm>
-            <a:off x="1920240" y="4892040"/>
-            <a:ext cx="1865376" cy="777240"/>
+            <a:off x="1920240" y="4937760"/>
+            <a:ext cx="1865376" cy="914400"/>
           </a:xfrm>
           <a:prstGeom prst="rect">
             <a:avLst/>
@@ -6504,8 +6477,8 @@
         </p:nvSpPr>
         <p:spPr>
           <a:xfrm>
-            <a:off x="4700016" y="4892040"/>
-            <a:ext cx="914400" cy="777240"/>
+            <a:off x="4700016" y="4937760"/>
+            <a:ext cx="914400" cy="914400"/>
           </a:xfrm>
           <a:prstGeom prst="rect">
             <a:avLst/>
@@ -6543,8 +6516,8 @@
         </p:nvSpPr>
         <p:spPr>
           <a:xfrm>
-            <a:off x="5614416" y="4892040"/>
-            <a:ext cx="1865376" cy="777240"/>
+            <a:off x="5614416" y="4937760"/>
+            <a:ext cx="1865376" cy="914400"/>
           </a:xfrm>
           <a:prstGeom prst="rect">
             <a:avLst/>
@@ -6609,8 +6582,8 @@
         </p:nvSpPr>
         <p:spPr>
           <a:xfrm>
-            <a:off x="8394192" y="4892040"/>
-            <a:ext cx="914400" cy="777240"/>
+            <a:off x="8394192" y="4937760"/>
+            <a:ext cx="914400" cy="914400"/>
           </a:xfrm>
           <a:prstGeom prst="rect">
             <a:avLst/>
@@ -6648,8 +6621,8 @@
         </p:nvSpPr>
         <p:spPr>
           <a:xfrm>
-            <a:off x="9308592" y="4892040"/>
-            <a:ext cx="1865376" cy="777240"/>
+            <a:off x="9308592" y="4937760"/>
+            <a:ext cx="1865376" cy="914400"/>
           </a:xfrm>
           <a:prstGeom prst="rect">
             <a:avLst/>
@@ -8787,17 +8760,17 @@
         </p:nvSpPr>
         <p:spPr>
           <a:xfrm>
-            <a:off x="941832" y="2990088"/>
-            <a:ext cx="2907792" cy="292608"/>
-          </a:xfrm>
-          <a:prstGeom prst="rect">
-            <a:avLst/>
-          </a:prstGeom>
-          <a:noFill/>
-          <a:ln/>
-        </p:spPr>
-        <p:txBody>
-          <a:bodyPr wrap="square" lIns="0" tIns="0" rIns="0" bIns="0" rtlCol="0" anchor="t"/>
+            <a:off x="941832" y="2953512"/>
+            <a:ext cx="2907792" cy="457200"/>
+          </a:xfrm>
+          <a:prstGeom prst="rect">
+            <a:avLst/>
+          </a:prstGeom>
+          <a:noFill/>
+          <a:ln/>
+        </p:spPr>
+        <p:txBody>
+          <a:bodyPr wrap="square" lIns="0" tIns="0" rIns="0" bIns="0" rtlCol="0" anchor="b"/>
           <a:lstStyle/>
           <a:p>
             <a:pPr algn="l" indent="0" marL="0">
@@ -8829,8 +8802,8 @@
         </p:nvSpPr>
         <p:spPr>
           <a:xfrm>
-            <a:off x="941832" y="3319272"/>
-            <a:ext cx="2907792" cy="749808"/>
+            <a:off x="941832" y="3465576"/>
+            <a:ext cx="2907792" cy="603504"/>
           </a:xfrm>
           <a:prstGeom prst="rect">
             <a:avLst/>
@@ -8898,17 +8871,17 @@
         </p:nvSpPr>
         <p:spPr>
           <a:xfrm>
-            <a:off x="4636008" y="2990088"/>
-            <a:ext cx="2907792" cy="292608"/>
-          </a:xfrm>
-          <a:prstGeom prst="rect">
-            <a:avLst/>
-          </a:prstGeom>
-          <a:noFill/>
-          <a:ln/>
-        </p:spPr>
-        <p:txBody>
-          <a:bodyPr wrap="square" lIns="0" tIns="0" rIns="0" bIns="0" rtlCol="0" anchor="t"/>
+            <a:off x="4636008" y="2953512"/>
+            <a:ext cx="2907792" cy="457200"/>
+          </a:xfrm>
+          <a:prstGeom prst="rect">
+            <a:avLst/>
+          </a:prstGeom>
+          <a:noFill/>
+          <a:ln/>
+        </p:spPr>
+        <p:txBody>
+          <a:bodyPr wrap="square" lIns="0" tIns="0" rIns="0" bIns="0" rtlCol="0" anchor="b"/>
           <a:lstStyle/>
           <a:p>
             <a:pPr algn="l" indent="0" marL="0">
@@ -8940,8 +8913,8 @@
         </p:nvSpPr>
         <p:spPr>
           <a:xfrm>
-            <a:off x="4636008" y="3319272"/>
-            <a:ext cx="2907792" cy="749808"/>
+            <a:off x="4636008" y="3465576"/>
+            <a:ext cx="2907792" cy="603504"/>
           </a:xfrm>
           <a:prstGeom prst="rect">
             <a:avLst/>
@@ -9009,17 +8982,17 @@
         </p:nvSpPr>
         <p:spPr>
           <a:xfrm>
-            <a:off x="8330184" y="2990088"/>
-            <a:ext cx="2907792" cy="292608"/>
-          </a:xfrm>
-          <a:prstGeom prst="rect">
-            <a:avLst/>
-          </a:prstGeom>
-          <a:noFill/>
-          <a:ln/>
-        </p:spPr>
-        <p:txBody>
-          <a:bodyPr wrap="square" lIns="0" tIns="0" rIns="0" bIns="0" rtlCol="0" anchor="t"/>
+            <a:off x="8330184" y="2953512"/>
+            <a:ext cx="2907792" cy="457200"/>
+          </a:xfrm>
+          <a:prstGeom prst="rect">
+            <a:avLst/>
+          </a:prstGeom>
+          <a:noFill/>
+          <a:ln/>
+        </p:spPr>
+        <p:txBody>
+          <a:bodyPr wrap="square" lIns="0" tIns="0" rIns="0" bIns="0" rtlCol="0" anchor="b"/>
           <a:lstStyle/>
           <a:p>
             <a:pPr algn="l" indent="0" marL="0">
@@ -9051,8 +9024,8 @@
         </p:nvSpPr>
         <p:spPr>
           <a:xfrm>
-            <a:off x="8330184" y="3319272"/>
-            <a:ext cx="2907792" cy="749808"/>
+            <a:off x="8330184" y="3465576"/>
+            <a:ext cx="2907792" cy="603504"/>
           </a:xfrm>
           <a:prstGeom prst="rect">
             <a:avLst/>
@@ -9120,17 +9093,17 @@
         </p:nvSpPr>
         <p:spPr>
           <a:xfrm>
-            <a:off x="941832" y="4471416"/>
-            <a:ext cx="2907792" cy="292608"/>
-          </a:xfrm>
-          <a:prstGeom prst="rect">
-            <a:avLst/>
-          </a:prstGeom>
-          <a:noFill/>
-          <a:ln/>
-        </p:spPr>
-        <p:txBody>
-          <a:bodyPr wrap="square" lIns="0" tIns="0" rIns="0" bIns="0" rtlCol="0" anchor="t"/>
+            <a:off x="941832" y="4434840"/>
+            <a:ext cx="2907792" cy="457200"/>
+          </a:xfrm>
+          <a:prstGeom prst="rect">
+            <a:avLst/>
+          </a:prstGeom>
+          <a:noFill/>
+          <a:ln/>
+        </p:spPr>
+        <p:txBody>
+          <a:bodyPr wrap="square" lIns="0" tIns="0" rIns="0" bIns="0" rtlCol="0" anchor="b"/>
           <a:lstStyle/>
           <a:p>
             <a:pPr algn="l" indent="0" marL="0">
@@ -9162,8 +9135,8 @@
         </p:nvSpPr>
         <p:spPr>
           <a:xfrm>
-            <a:off x="941832" y="4800600"/>
-            <a:ext cx="2907792" cy="749808"/>
+            <a:off x="941832" y="4946904"/>
+            <a:ext cx="2907792" cy="603504"/>
           </a:xfrm>
           <a:prstGeom prst="rect">
             <a:avLst/>
@@ -9231,17 +9204,17 @@
         </p:nvSpPr>
         <p:spPr>
           <a:xfrm>
-            <a:off x="4636008" y="4471416"/>
-            <a:ext cx="2907792" cy="292608"/>
-          </a:xfrm>
-          <a:prstGeom prst="rect">
-            <a:avLst/>
-          </a:prstGeom>
-          <a:noFill/>
-          <a:ln/>
-        </p:spPr>
-        <p:txBody>
-          <a:bodyPr wrap="square" lIns="0" tIns="0" rIns="0" bIns="0" rtlCol="0" anchor="t"/>
+            <a:off x="4636008" y="4434840"/>
+            <a:ext cx="2907792" cy="457200"/>
+          </a:xfrm>
+          <a:prstGeom prst="rect">
+            <a:avLst/>
+          </a:prstGeom>
+          <a:noFill/>
+          <a:ln/>
+        </p:spPr>
+        <p:txBody>
+          <a:bodyPr wrap="square" lIns="0" tIns="0" rIns="0" bIns="0" rtlCol="0" anchor="b"/>
           <a:lstStyle/>
           <a:p>
             <a:pPr algn="l" indent="0" marL="0">
@@ -9273,8 +9246,8 @@
         </p:nvSpPr>
         <p:spPr>
           <a:xfrm>
-            <a:off x="4636008" y="4800600"/>
-            <a:ext cx="2907792" cy="749808"/>
+            <a:off x="4636008" y="4946904"/>
+            <a:ext cx="2907792" cy="603504"/>
           </a:xfrm>
           <a:prstGeom prst="rect">
             <a:avLst/>
@@ -9342,17 +9315,17 @@
         </p:nvSpPr>
         <p:spPr>
           <a:xfrm>
-            <a:off x="8330184" y="4471416"/>
-            <a:ext cx="2907792" cy="292608"/>
-          </a:xfrm>
-          <a:prstGeom prst="rect">
-            <a:avLst/>
-          </a:prstGeom>
-          <a:noFill/>
-          <a:ln/>
-        </p:spPr>
-        <p:txBody>
-          <a:bodyPr wrap="square" lIns="0" tIns="0" rIns="0" bIns="0" rtlCol="0" anchor="t"/>
+            <a:off x="8330184" y="4434840"/>
+            <a:ext cx="2907792" cy="457200"/>
+          </a:xfrm>
+          <a:prstGeom prst="rect">
+            <a:avLst/>
+          </a:prstGeom>
+          <a:noFill/>
+          <a:ln/>
+        </p:spPr>
+        <p:txBody>
+          <a:bodyPr wrap="square" lIns="0" tIns="0" rIns="0" bIns="0" rtlCol="0" anchor="b"/>
           <a:lstStyle/>
           <a:p>
             <a:pPr algn="l" indent="0" marL="0">
@@ -9384,8 +9357,8 @@
         </p:nvSpPr>
         <p:spPr>
           <a:xfrm>
-            <a:off x="8330184" y="4800600"/>
-            <a:ext cx="2907792" cy="749808"/>
+            <a:off x="8330184" y="4946904"/>
+            <a:ext cx="2907792" cy="603504"/>
           </a:xfrm>
           <a:prstGeom prst="rect">
             <a:avLst/>
@@ -9420,41 +9393,14 @@
       </p:sp>
       <p:sp>
         <p:nvSpPr>
-          <p:cNvPr id="43" name="Shape 41"/>
-          <p:cNvSpPr/>
-          <p:nvPr/>
-        </p:nvSpPr>
-        <p:spPr>
-          <a:xfrm>
-            <a:off x="685800" y="5760720"/>
-            <a:ext cx="10820095" cy="658368"/>
-          </a:xfrm>
-          <a:prstGeom prst="roundRect">
-            <a:avLst>
-              <a:gd name="adj" fmla="val 12500"/>
-            </a:avLst>
-          </a:prstGeom>
-          <a:solidFill>
-            <a:srgbClr val="0E1B25"/>
-          </a:solidFill>
-          <a:ln w="12700">
-            <a:solidFill>
-              <a:srgbClr val="27405A"/>
-            </a:solidFill>
-            <a:prstDash val="solid"/>
-          </a:ln>
-        </p:spPr>
-      </p:sp>
-      <p:sp>
-        <p:nvSpPr>
-          <p:cNvPr id="44" name="Text 42"/>
-          <p:cNvSpPr/>
-          <p:nvPr/>
-        </p:nvSpPr>
-        <p:spPr>
-          <a:xfrm>
-            <a:off x="960120" y="5961888"/>
-            <a:ext cx="10271455" cy="292608"/>
+          <p:cNvPr id="43" name="Text 41"/>
+          <p:cNvSpPr/>
+          <p:nvPr/>
+        </p:nvSpPr>
+        <p:spPr>
+          <a:xfrm>
+            <a:off x="685800" y="5897880"/>
+            <a:ext cx="9966960" cy="274320"/>
           </a:xfrm>
           <a:prstGeom prst="rect">
             <a:avLst/>
@@ -9481,7 +9427,49 @@
                 <a:ea typeface="Calibri" pitchFamily="34" charset="-122"/>
                 <a:cs typeface="Calibri" pitchFamily="34" charset="-120"/>
               </a:rPr>
-              <a:t>Node ≥ 20, Postgres 16, én produksjonsavhengighet. 15 migrasjoner, 19 testfiler over sju testnivåer. Drift i EU/EØS.   ·   Ingen av dette er i produksjon med ekte brukere.</a:t>
+              <a:t>Node ≥ 20, Postgres 16, én produksjonsavhengighet. 15 migrasjoner, 19 testfiler over sju testnivåer. Drift i EU/EØS.</a:t>
+            </a:r>
+            <a:endParaRPr lang="en-US" sz="1150" dirty="0"/>
+          </a:p>
+        </p:txBody>
+      </p:sp>
+      <p:sp>
+        <p:nvSpPr>
+          <p:cNvPr id="44" name="Text 42"/>
+          <p:cNvSpPr/>
+          <p:nvPr/>
+        </p:nvSpPr>
+        <p:spPr>
+          <a:xfrm>
+            <a:off x="685800" y="6217920"/>
+            <a:ext cx="9966960" cy="274320"/>
+          </a:xfrm>
+          <a:prstGeom prst="rect">
+            <a:avLst/>
+          </a:prstGeom>
+          <a:noFill/>
+          <a:ln/>
+        </p:spPr>
+        <p:txBody>
+          <a:bodyPr wrap="square" lIns="0" tIns="0" rIns="0" bIns="0" rtlCol="0" anchor="t"/>
+          <a:lstStyle/>
+          <a:p>
+            <a:pPr algn="l" indent="0" marL="0">
+              <a:lnSpc>
+                <a:spcPts val="1633"/>
+              </a:lnSpc>
+              <a:buNone/>
+            </a:pPr>
+            <a:r>
+              <a:rPr lang="en-US" sz="1150" dirty="0">
+                <a:solidFill>
+                  <a:srgbClr val="D9B36B"/>
+                </a:solidFill>
+                <a:latin typeface="Calibri" pitchFamily="34" charset="0"/>
+                <a:ea typeface="Calibri" pitchFamily="34" charset="-122"/>
+                <a:cs typeface="Calibri" pitchFamily="34" charset="-120"/>
+              </a:rPr>
+              <a:t>Ingen av dette er i produksjon med ekte brukere.</a:t>
             </a:r>
             <a:endParaRPr lang="en-US" sz="1150" dirty="0"/>
           </a:p>
@@ -9606,7 +9594,7 @@
         <p:spPr>
           <a:xfrm>
             <a:off x="685800" y="868680"/>
-            <a:ext cx="6400800" cy="868680"/>
+            <a:ext cx="5669280" cy="868680"/>
           </a:xfrm>
           <a:prstGeom prst="rect">
             <a:avLst/>
@@ -9690,11 +9678,11 @@
         <p:spPr>
           <a:xfrm>
             <a:off x="685800" y="3063240"/>
-            <a:ext cx="5120640" cy="2286000"/>
+            <a:ext cx="5120640" cy="1920240"/>
           </a:xfrm>
           <a:prstGeom prst="roundRect">
             <a:avLst>
-              <a:gd name="adj" fmla="val 3600"/>
+              <a:gd name="adj" fmla="val 4286"/>
             </a:avLst>
           </a:prstGeom>
           <a:solidFill>
@@ -10005,7 +9993,7 @@
                 <a:ea typeface="Calibri" pitchFamily="34" charset="-122"/>
                 <a:cs typeface="Calibri" pitchFamily="34" charset="-120"/>
               </a:rPr>
-              <a:t>SKJERMBILDE FRA APPEN · DEMO-TENANT «ALFA» · 390×844</a:t>
+              <a:t>SKJERMBILDE FRA APPEN · DEMODATA · 390×844</a:t>
             </a:r>
             <a:endParaRPr lang="en-US" sz="900" dirty="0"/>
           </a:p>
@@ -10469,7 +10457,7 @@
                 <a:ea typeface="Calibri" pitchFamily="34" charset="-122"/>
                 <a:cs typeface="Calibri" pitchFamily="34" charset="-120"/>
               </a:rPr>
-              <a:t>SKJERMBILDE FRA APPEN · DEMO-TENANT «ALFA» · 390×844</a:t>
+              <a:t>SKJERMBILDE FRA APPEN · DEMODATA · 390×844</a:t>
             </a:r>
             <a:endParaRPr lang="en-US" sz="900" dirty="0"/>
           </a:p>
@@ -10953,7 +10941,7 @@
                 <a:ea typeface="Calibri" pitchFamily="34" charset="-122"/>
                 <a:cs typeface="Calibri" pitchFamily="34" charset="-120"/>
               </a:rPr>
-              <a:t>SKJERMBILDE FRA APPEN · DEMO-TENANT «ALFA» · 390×844</a:t>
+              <a:t>SKJERMBILDE FRA APPEN · DEMODATA · 390×844</a:t>
             </a:r>
             <a:endParaRPr lang="en-US" sz="900" dirty="0"/>
           </a:p>
@@ -11161,7 +11149,7 @@
         </p:nvSpPr>
         <p:spPr>
           <a:xfrm>
-            <a:off x="1097280" y="2697480"/>
+            <a:off x="1097280" y="2633472"/>
             <a:ext cx="4206240" cy="219456"/>
           </a:xfrm>
           <a:prstGeom prst="rect">
@@ -11200,7 +11188,7 @@
         </p:nvSpPr>
         <p:spPr>
           <a:xfrm>
-            <a:off x="5806440" y="2697480"/>
+            <a:off x="5806440" y="2633472"/>
             <a:ext cx="5669280" cy="219456"/>
           </a:xfrm>
           <a:prstGeom prst="rect">
@@ -11239,7 +11227,7 @@
         </p:nvSpPr>
         <p:spPr>
           <a:xfrm>
-            <a:off x="685800" y="3017520"/>
+            <a:off x="685800" y="2944368"/>
             <a:ext cx="365760" cy="457200"/>
           </a:xfrm>
           <a:prstGeom prst="rect">
@@ -11278,7 +11266,7 @@
         </p:nvSpPr>
         <p:spPr>
           <a:xfrm>
-            <a:off x="1097280" y="3017520"/>
+            <a:off x="1097280" y="2944368"/>
             <a:ext cx="4480560" cy="457200"/>
           </a:xfrm>
           <a:prstGeom prst="rect">
@@ -11337,7 +11325,7 @@
         </p:nvSpPr>
         <p:spPr>
           <a:xfrm>
-            <a:off x="5806440" y="3017520"/>
+            <a:off x="5806440" y="2944368"/>
             <a:ext cx="5669280" cy="457200"/>
           </a:xfrm>
           <a:prstGeom prst="rect">
@@ -11379,7 +11367,7 @@
         </p:nvSpPr>
         <p:spPr>
           <a:xfrm>
-            <a:off x="685800" y="3566160"/>
+            <a:off x="685800" y="3456432"/>
             <a:ext cx="365760" cy="457200"/>
           </a:xfrm>
           <a:prstGeom prst="rect">
@@ -11418,7 +11406,7 @@
         </p:nvSpPr>
         <p:spPr>
           <a:xfrm>
-            <a:off x="1097280" y="3566160"/>
+            <a:off x="1097280" y="3456432"/>
             <a:ext cx="4480560" cy="457200"/>
           </a:xfrm>
           <a:prstGeom prst="rect">
@@ -11477,7 +11465,7 @@
         </p:nvSpPr>
         <p:spPr>
           <a:xfrm>
-            <a:off x="5806440" y="3566160"/>
+            <a:off x="5806440" y="3456432"/>
             <a:ext cx="5669280" cy="457200"/>
           </a:xfrm>
           <a:prstGeom prst="rect">
@@ -11519,7 +11507,7 @@
         </p:nvSpPr>
         <p:spPr>
           <a:xfrm>
-            <a:off x="685800" y="4114800"/>
+            <a:off x="685800" y="3968496"/>
             <a:ext cx="365760" cy="457200"/>
           </a:xfrm>
           <a:prstGeom prst="rect">
@@ -11558,7 +11546,7 @@
         </p:nvSpPr>
         <p:spPr>
           <a:xfrm>
-            <a:off x="1097280" y="4114800"/>
+            <a:off x="1097280" y="3968496"/>
             <a:ext cx="4480560" cy="457200"/>
           </a:xfrm>
           <a:prstGeom prst="rect">
@@ -11617,7 +11605,7 @@
         </p:nvSpPr>
         <p:spPr>
           <a:xfrm>
-            <a:off x="5806440" y="4114800"/>
+            <a:off x="5806440" y="3968496"/>
             <a:ext cx="5669280" cy="457200"/>
           </a:xfrm>
           <a:prstGeom prst="rect">
@@ -11659,7 +11647,7 @@
         </p:nvSpPr>
         <p:spPr>
           <a:xfrm>
-            <a:off x="685800" y="4663440"/>
+            <a:off x="685800" y="4480560"/>
             <a:ext cx="365760" cy="457200"/>
           </a:xfrm>
           <a:prstGeom prst="rect">
@@ -11698,7 +11686,7 @@
         </p:nvSpPr>
         <p:spPr>
           <a:xfrm>
-            <a:off x="1097280" y="4663440"/>
+            <a:off x="1097280" y="4480560"/>
             <a:ext cx="4480560" cy="457200"/>
           </a:xfrm>
           <a:prstGeom prst="rect">
@@ -11757,7 +11745,7 @@
         </p:nvSpPr>
         <p:spPr>
           <a:xfrm>
-            <a:off x="5806440" y="4663440"/>
+            <a:off x="5806440" y="4480560"/>
             <a:ext cx="5669280" cy="457200"/>
           </a:xfrm>
           <a:prstGeom prst="rect">
@@ -11799,7 +11787,7 @@
         </p:nvSpPr>
         <p:spPr>
           <a:xfrm>
-            <a:off x="685800" y="5212080"/>
+            <a:off x="685800" y="4992624"/>
             <a:ext cx="365760" cy="457200"/>
           </a:xfrm>
           <a:prstGeom prst="rect">
@@ -11838,7 +11826,7 @@
         </p:nvSpPr>
         <p:spPr>
           <a:xfrm>
-            <a:off x="1097280" y="5212080"/>
+            <a:off x="1097280" y="4992624"/>
             <a:ext cx="4480560" cy="457200"/>
           </a:xfrm>
           <a:prstGeom prst="rect">
@@ -11897,7 +11885,7 @@
         </p:nvSpPr>
         <p:spPr>
           <a:xfrm>
-            <a:off x="5806440" y="5212080"/>
+            <a:off x="5806440" y="4992624"/>
             <a:ext cx="5669280" cy="457200"/>
           </a:xfrm>
           <a:prstGeom prst="rect">
@@ -11939,7 +11927,7 @@
         </p:nvSpPr>
         <p:spPr>
           <a:xfrm>
-            <a:off x="685800" y="5760720"/>
+            <a:off x="685800" y="5504688"/>
             <a:ext cx="365760" cy="457200"/>
           </a:xfrm>
           <a:prstGeom prst="rect">
@@ -11978,7 +11966,7 @@
         </p:nvSpPr>
         <p:spPr>
           <a:xfrm>
-            <a:off x="1097280" y="5760720"/>
+            <a:off x="1097280" y="5504688"/>
             <a:ext cx="4480560" cy="457200"/>
           </a:xfrm>
           <a:prstGeom prst="rect">
@@ -12037,7 +12025,7 @@
         </p:nvSpPr>
         <p:spPr>
           <a:xfrm>
-            <a:off x="5806440" y="5760720"/>
+            <a:off x="5806440" y="5504688"/>
             <a:ext cx="5669280" cy="457200"/>
           </a:xfrm>
           <a:prstGeom prst="rect">
@@ -12079,8 +12067,8 @@
         </p:nvSpPr>
         <p:spPr>
           <a:xfrm>
-            <a:off x="685800" y="6355080"/>
-            <a:ext cx="10424160" cy="457200"/>
+            <a:off x="685800" y="6108192"/>
+            <a:ext cx="9966960" cy="548640"/>
           </a:xfrm>
           <a:prstGeom prst="rect">
             <a:avLst/>
@@ -12094,12 +12082,12 @@
           <a:p>
             <a:pPr algn="l" indent="0" marL="0">
               <a:lnSpc>
-                <a:spcPts val="1704"/>
-              </a:lnSpc>
-              <a:buNone/>
-            </a:pPr>
-            <a:r>
-              <a:rPr lang="en-US" sz="1200" dirty="0">
+                <a:spcPts val="1633"/>
+              </a:lnSpc>
+              <a:buNone/>
+            </a:pPr>
+            <a:r>
+              <a:rPr lang="en-US" sz="1150" dirty="0">
                 <a:solidFill>
                   <a:srgbClr val="EDF2F0"/>
                 </a:solidFill>
@@ -12109,7 +12097,7 @@
               </a:rPr>
               <a:t>Bytt om på to av dem, og systemet er ødelagt uten å se ødelagt ut. Det som ikke kan kopieres i det hele tatt, er svaret på spørsmålet kunden faktisk stiller: «finnes dere den dagen dette trengs?»</a:t>
             </a:r>
-            <a:endParaRPr lang="en-US" sz="1200" dirty="0"/>
+            <a:endParaRPr lang="en-US" sz="1150" dirty="0"/>
           </a:p>
         </p:txBody>
       </p:sp>

</xml_diff>